<commit_message>
feat(inventory): persistencia real de inventario, traslados express y resolucion de quiebre amoxidal 500mg
</commit_message>
<xml_diff>
--- a/PRUEBAS_SISTEMA_SIIP_FARMACIAS.pptx
+++ b/PRUEBAS_SISTEMA_SIIP_FARMACIAS.pptx
@@ -313,7 +313,7 @@
           <a:p>
             <a:fld id="{5BCAD085-E8A6-8845-BD4E-CB4CCA059FC4}" type="datetimeFigureOut">
               <a:rPr lang="en-US" smtClean="0"/>
-              <a:t>10/25/2026</a:t>
+              <a:t>10/26/2026</a:t>
             </a:fld>
             <a:endParaRPr lang="en-US"/>
           </a:p>
@@ -481,7 +481,7 @@
           <a:p>
             <a:fld id="{5BCAD085-E8A6-8845-BD4E-CB4CCA059FC4}" type="datetimeFigureOut">
               <a:rPr lang="en-US" smtClean="0"/>
-              <a:t>10/25/2026</a:t>
+              <a:t>10/26/2026</a:t>
             </a:fld>
             <a:endParaRPr lang="en-US"/>
           </a:p>
@@ -659,7 +659,7 @@
           <a:p>
             <a:fld id="{5BCAD085-E8A6-8845-BD4E-CB4CCA059FC4}" type="datetimeFigureOut">
               <a:rPr lang="en-US" smtClean="0"/>
-              <a:t>10/25/2026</a:t>
+              <a:t>10/26/2026</a:t>
             </a:fld>
             <a:endParaRPr lang="en-US"/>
           </a:p>
@@ -827,7 +827,7 @@
           <a:p>
             <a:fld id="{5BCAD085-E8A6-8845-BD4E-CB4CCA059FC4}" type="datetimeFigureOut">
               <a:rPr lang="en-US" smtClean="0"/>
-              <a:t>10/25/2026</a:t>
+              <a:t>10/26/2026</a:t>
             </a:fld>
             <a:endParaRPr lang="en-US"/>
           </a:p>
@@ -1072,7 +1072,7 @@
           <a:p>
             <a:fld id="{5BCAD085-E8A6-8845-BD4E-CB4CCA059FC4}" type="datetimeFigureOut">
               <a:rPr lang="en-US" smtClean="0"/>
-              <a:t>10/25/2026</a:t>
+              <a:t>10/26/2026</a:t>
             </a:fld>
             <a:endParaRPr lang="en-US"/>
           </a:p>
@@ -1357,7 +1357,7 @@
           <a:p>
             <a:fld id="{5BCAD085-E8A6-8845-BD4E-CB4CCA059FC4}" type="datetimeFigureOut">
               <a:rPr lang="en-US" smtClean="0"/>
-              <a:t>10/25/2026</a:t>
+              <a:t>10/26/2026</a:t>
             </a:fld>
             <a:endParaRPr lang="en-US"/>
           </a:p>
@@ -1776,7 +1776,7 @@
           <a:p>
             <a:fld id="{5BCAD085-E8A6-8845-BD4E-CB4CCA059FC4}" type="datetimeFigureOut">
               <a:rPr lang="en-US" smtClean="0"/>
-              <a:t>10/25/2026</a:t>
+              <a:t>10/26/2026</a:t>
             </a:fld>
             <a:endParaRPr lang="en-US"/>
           </a:p>
@@ -1893,7 +1893,7 @@
           <a:p>
             <a:fld id="{5BCAD085-E8A6-8845-BD4E-CB4CCA059FC4}" type="datetimeFigureOut">
               <a:rPr lang="en-US" smtClean="0"/>
-              <a:t>10/25/2026</a:t>
+              <a:t>10/26/2026</a:t>
             </a:fld>
             <a:endParaRPr lang="en-US"/>
           </a:p>
@@ -1988,7 +1988,7 @@
           <a:p>
             <a:fld id="{5BCAD085-E8A6-8845-BD4E-CB4CCA059FC4}" type="datetimeFigureOut">
               <a:rPr lang="en-US" smtClean="0"/>
-              <a:t>10/25/2026</a:t>
+              <a:t>10/26/2026</a:t>
             </a:fld>
             <a:endParaRPr lang="en-US"/>
           </a:p>
@@ -2263,7 +2263,7 @@
           <a:p>
             <a:fld id="{5BCAD085-E8A6-8845-BD4E-CB4CCA059FC4}" type="datetimeFigureOut">
               <a:rPr lang="en-US" smtClean="0"/>
-              <a:t>10/25/2026</a:t>
+              <a:t>10/26/2026</a:t>
             </a:fld>
             <a:endParaRPr lang="en-US"/>
           </a:p>
@@ -2515,7 +2515,7 @@
           <a:p>
             <a:fld id="{5BCAD085-E8A6-8845-BD4E-CB4CCA059FC4}" type="datetimeFigureOut">
               <a:rPr lang="en-US" smtClean="0"/>
-              <a:t>10/25/2026</a:t>
+              <a:t>10/26/2026</a:t>
             </a:fld>
             <a:endParaRPr lang="en-US"/>
           </a:p>
@@ -2726,7 +2726,7 @@
           <a:p>
             <a:fld id="{5BCAD085-E8A6-8845-BD4E-CB4CCA059FC4}" type="datetimeFigureOut">
               <a:rPr lang="en-US" smtClean="0"/>
-              <a:t>10/25/2026</a:t>
+              <a:t>10/26/2026</a:t>
             </a:fld>
             <a:endParaRPr lang="en-US"/>
           </a:p>
@@ -3198,7 +3198,7 @@
         <p:spPr>
           <a:xfrm>
             <a:off x="1097280" y="1097280"/>
-            <a:ext cx="10058400" cy="3724096"/>
+            <a:ext cx="10058400" cy="4001095"/>
           </a:xfrm>
           <a:prstGeom prst="rect">
             <a:avLst/>
@@ -3365,7 +3365,7 @@
             </a:br>
             <a:r>
               <a:rPr lang="es-ES" dirty="0"/>
-              <a:t>   </a:t>
+              <a:t>   	- </a:t>
             </a:r>
             <a:r>
               <a:rPr dirty="0"/>
@@ -3391,12 +3391,34 @@
               <a:rPr lang="es-ES" dirty="0"/>
             </a:br>
             <a:r>
-              <a:rPr lang="es-ES"/>
-              <a:t>   Herrera Villanueva Luis Javier (Cod U24327771</a:t>
+              <a:rPr lang="es-ES" dirty="0"/>
+              <a:t>   	- Herrera Villanueva Luis Javier (Cod U24327771</a:t>
             </a:r>
             <a:r>
               <a:rPr lang="pt-BR" dirty="0"/>
               <a:t>)</a:t>
+            </a:r>
+          </a:p>
+          <a:p>
+            <a:r>
+              <a:rPr lang="pt-BR" dirty="0"/>
+              <a:t>	- Richard Martin </a:t>
+            </a:r>
+            <a:r>
+              <a:rPr lang="pt-BR" dirty="0" err="1"/>
+              <a:t>Ticona</a:t>
+            </a:r>
+            <a:r>
+              <a:rPr lang="pt-BR" dirty="0"/>
+              <a:t> Condor (</a:t>
+            </a:r>
+            <a:r>
+              <a:rPr lang="pt-BR" dirty="0" err="1"/>
+              <a:t>Cod</a:t>
+            </a:r>
+            <a:r>
+              <a:rPr lang="pt-BR" dirty="0"/>
+              <a:t> U23246612)</a:t>
             </a:r>
             <a:br>
               <a:rPr dirty="0"/>

</xml_diff>